<commit_message>
Remove speech draft, keep PPT and outline only
</commit_message>
<xml_diff>
--- a/FitPilot_Presentation.pptx
+++ b/FitPilot_Presentation.pptx
@@ -11109,7 +11109,7 @@
         <p:spPr>
           <a:xfrm>
             <a:off x="822960" y="4023360"/>
-            <a:ext cx="10515600" cy="548640"/>
+            <a:ext cx="10515600" cy="661720"/>
           </a:xfrm>
           <a:prstGeom prst="rect">
             <a:avLst/>
@@ -11122,10 +11122,7 @@
           </a:bodyPr>
           <a:lstStyle/>
           <a:p>
-            <a:pPr algn="l">
-              <a:lnSpc>
-                <a:spcPct val="100000"/>
-              </a:lnSpc>
+            <a:pPr>
               <a:spcAft>
                 <a:spcPts val="600"/>
               </a:spcAft>
@@ -11137,16 +11134,46 @@
                 </a:solidFill>
                 <a:latin typeface="Calibri"/>
               </a:rPr>
-              <a:t>GitHub: github.com/your-team/</a:t>
-            </a:r>
-            <a:r>
-              <a:rPr sz="1600" b="0" i="0" dirty="0" err="1">
+              <a:t>GitHub: </a:t>
+            </a:r>
+            <a:r>
+              <a:rPr lang="en-US" sz="1600" dirty="0">
                 <a:solidFill>
                   <a:srgbClr val="52525B"/>
                 </a:solidFill>
-                <a:latin typeface="Calibri"/>
-              </a:rPr>
-              <a:t>fitpilot</a:t>
+                <a:hlinkClick r:id="rId2"/>
+              </a:rPr>
+              <a:t>https://</a:t>
+            </a:r>
+            <a:r>
+              <a:rPr lang="en-US" sz="1600" dirty="0" smtClean="0">
+                <a:solidFill>
+                  <a:srgbClr val="52525B"/>
+                </a:solidFill>
+                <a:hlinkClick r:id="rId2"/>
+              </a:rPr>
+              <a:t>github.com/Arthur-118/FitPilot</a:t>
+            </a:r>
+            <a:endParaRPr lang="en-US" sz="1600" dirty="0" smtClean="0">
+              <a:solidFill>
+                <a:srgbClr val="52525B"/>
+              </a:solidFill>
+            </a:endParaRPr>
+          </a:p>
+          <a:p>
+            <a:pPr>
+              <a:spcAft>
+                <a:spcPts val="600"/>
+              </a:spcAft>
+            </a:pPr>
+            <a:r>
+              <a:rPr sz="1600" b="0" i="0" dirty="0" smtClean="0">
+                <a:solidFill>
+                  <a:srgbClr val="52525B"/>
+                </a:solidFill>
+                <a:latin typeface="Calibri"/>
+              </a:rPr>
+              <a:t>Questions welcome</a:t>
             </a:r>
             <a:endParaRPr sz="1600" b="0" i="0" dirty="0">
               <a:solidFill>
@@ -11154,25 +11181,6 @@
               </a:solidFill>
               <a:latin typeface="Calibri"/>
             </a:endParaRPr>
-          </a:p>
-          <a:p>
-            <a:pPr algn="l">
-              <a:lnSpc>
-                <a:spcPct val="100000"/>
-              </a:lnSpc>
-              <a:spcAft>
-                <a:spcPts val="600"/>
-              </a:spcAft>
-            </a:pPr>
-            <a:r>
-              <a:rPr sz="1600" b="0" i="0" dirty="0">
-                <a:solidFill>
-                  <a:srgbClr val="52525B"/>
-                </a:solidFill>
-                <a:latin typeface="Calibri"/>
-              </a:rPr>
-              <a:t>Questions welcome</a:t>
-            </a:r>
           </a:p>
         </p:txBody>
       </p:sp>

</xml_diff>